<commit_message>
Update typo in slides
</commit_message>
<xml_diff>
--- a/slides.pptx
+++ b/slides.pptx
@@ -42,7 +42,7 @@
       <p:boldItalic r:id="rId28"/>
     </p:embeddedFont>
     <p:embeddedFont>
-      <p:font typeface="Noto Sans Bold" panose="020B0802040504020204" charset="0"/>
+      <p:font typeface="Noto Sans Bold" panose="020B0802040504020204" pitchFamily="34" charset="0"/>
       <p:regular r:id="rId29"/>
       <p:bold r:id="rId30"/>
     </p:embeddedFont>
@@ -9783,13 +9783,22 @@
               <a:defRPr/>
             </a:pPr>
             <a:r>
+              <a:rPr lang="en-US" sz="2400" spc="38">
+                <a:latin typeface="Noto Sans"/>
+                <a:ea typeface="Noto Sans"/>
+                <a:cs typeface="Noto Sans"/>
+                <a:sym typeface="Noto Sans"/>
+              </a:rPr>
+              <a:t>Akademie </a:t>
+            </a:r>
+            <a:r>
               <a:rPr lang="en-US" sz="2400" spc="38" dirty="0">
                 <a:latin typeface="Noto Sans"/>
                 <a:ea typeface="Noto Sans"/>
                 <a:cs typeface="Noto Sans"/>
                 <a:sym typeface="Noto Sans"/>
               </a:rPr>
-              <a:t>Academie der </a:t>
+              <a:t>der </a:t>
             </a:r>
             <a:r>
               <a:rPr lang="en-US" sz="2400" spc="38" dirty="0" err="1">

</xml_diff>